<commit_message>
Info session poster: wire in real Zoom details for May 9
- Time: Saturday, May 9, 2026 · 11:00 AM EDT (6:00 PM EAT)
- Zoom: duke.zoom.us/j/96991939005
- Meeting ID: 969 9193 9005
- No passcode (Duke link embeds it); render skips the passcode
  line gracefully when zoomPass is empty.
- Bumped Zoom URL to 22pt so it reads clearly at flyer scale.
</commit_message>
<xml_diff>
--- a/outputs/flyers/USMLE_InfoSession_Poster.pptx
+++ b/outputs/flyers/USMLE_InfoSession_Poster.pptx
@@ -1217,7 +1217,7 @@
                 <a:ea typeface="Calibri" pitchFamily="34" charset="-122"/>
                 <a:cs typeface="Calibri" pitchFamily="34" charset="-120"/>
               </a:rPr>
-              <a:t>7:00 PM EAT  ·  12:00 PM EDT</a:t>
+              <a:t>11:00 AM EDT  ·  6:00 PM EAT</a:t>
             </a:r>
             <a:endParaRPr lang="en-US" sz="1000" dirty="0"/>
           </a:p>
@@ -2434,7 +2434,7 @@
                 <a:ea typeface="Calibri" pitchFamily="34" charset="-122"/>
                 <a:cs typeface="Calibri" pitchFamily="34" charset="-120"/>
               </a:rPr>
-              <a:t>Saturday, May 9, 2026  ·  7:00 PM EAT  ·  12:00 PM EDT</a:t>
+              <a:t>Saturday, May 9, 2026  ·  11:00 AM EDT  ·  6:00 PM EAT</a:t>
             </a:r>
             <a:endParaRPr lang="en-US" sz="1400" dirty="0"/>
           </a:p>
@@ -2465,7 +2465,7 @@
               <a:buNone/>
             </a:pPr>
             <a:r>
-              <a:rPr lang="en-US" sz="1800" b="1" dirty="0">
+              <a:rPr lang="en-US" sz="2200" b="1" dirty="0">
                 <a:solidFill>
                   <a:srgbClr val="FFFFFF"/>
                 </a:solidFill>
@@ -2473,9 +2473,9 @@
                 <a:ea typeface="Arial Black" pitchFamily="34" charset="-122"/>
                 <a:cs typeface="Arial Black" pitchFamily="34" charset="-120"/>
               </a:rPr>
-              <a:t>https://us02web.zoom.us/j/PLACEHOLDER</a:t>
-            </a:r>
-            <a:endParaRPr lang="en-US" sz="1800" dirty="0"/>
+              <a:t>duke.zoom.us/j/96991939005</a:t>
+            </a:r>
+            <a:endParaRPr lang="en-US" sz="2200" dirty="0"/>
           </a:p>
         </p:txBody>
       </p:sp>
@@ -2504,7 +2504,7 @@
               <a:buNone/>
             </a:pPr>
             <a:r>
-              <a:rPr lang="en-US" sz="1150" dirty="0">
+              <a:rPr lang="en-US" sz="1200" dirty="0">
                 <a:solidFill>
                   <a:srgbClr val="FFFFFF"/>
                 </a:solidFill>
@@ -2512,9 +2512,9 @@
                 <a:ea typeface="Calibri" pitchFamily="34" charset="-122"/>
                 <a:cs typeface="Calibri" pitchFamily="34" charset="-120"/>
               </a:rPr>
-              <a:t>Meeting ID: PLACEHOLDER    ·    Passcode: PLACEHOLDER</a:t>
-            </a:r>
-            <a:endParaRPr lang="en-US" sz="1150" dirty="0"/>
+              <a:t>Meeting ID: 969 9193 9005</a:t>
+            </a:r>
+            <a:endParaRPr lang="en-US" sz="1200" dirty="0"/>
           </a:p>
         </p:txBody>
       </p:sp>

</xml_diff>

<commit_message>
Info session: drop cost/enrollment, lead with USMLE journey overview
This session is informational only — about the USMLE, the
residency path, requirements, and what the classes look like.
Pricing and payment talk happens 1:1 after the session.

Card sequence is now:
  1. The USMLE & residency path  (what's tested, IMG eligibility, timeline)
  2. Course structure             (daily classes, 4-month roadmap)
  3. Materials & resources        (textbook, Qbank, supplements)
  4. End-to-end mentorship        (ECFMG, CV, PS, interviews, match)
</commit_message>
<xml_diff>
--- a/outputs/flyers/USMLE_InfoSession_Poster.pptx
+++ b/outputs/flyers/USMLE_InfoSession_Poster.pptx
@@ -1645,7 +1645,7 @@
                 <a:ea typeface="Calibri" pitchFamily="34" charset="-122"/>
                 <a:cs typeface="Calibri" pitchFamily="34" charset="-120"/>
               </a:rPr>
-              <a:t>Course structure</a:t>
+              <a:t>The USMLE &amp; residency path</a:t>
             </a:r>
             <a:endParaRPr lang="en-US" sz="1500" dirty="0"/>
           </a:p>
@@ -1684,7 +1684,7 @@
                 <a:ea typeface="Calibri" pitchFamily="34" charset="-122"/>
                 <a:cs typeface="Calibri" pitchFamily="34" charset="-120"/>
               </a:rPr>
-              <a:t>Daily Mon–Sun classes, 4-month roadmap, how the syllabus flows topic-by-topic.</a:t>
+              <a:t>What Step 1 &amp; Step 2 CK actually test, eligibility for IMGs, and the prep + match timeline overview.</a:t>
             </a:r>
             <a:endParaRPr lang="en-US" sz="1150" dirty="0"/>
           </a:p>
@@ -1844,7 +1844,7 @@
                 <a:ea typeface="Calibri" pitchFamily="34" charset="-122"/>
                 <a:cs typeface="Calibri" pitchFamily="34" charset="-120"/>
               </a:rPr>
-              <a:t>Materials &amp; resources</a:t>
+              <a:t>Course structure</a:t>
             </a:r>
             <a:endParaRPr lang="en-US" sz="1500" dirty="0"/>
           </a:p>
@@ -1883,7 +1883,7 @@
                 <a:ea typeface="Calibri" pitchFamily="34" charset="-122"/>
                 <a:cs typeface="Calibri" pitchFamily="34" charset="-120"/>
               </a:rPr>
-              <a:t>Recommended textbook, Qbank, and curated supplements walked through together.</a:t>
+              <a:t>Daily Mon–Sun classes, 4-month roadmap, how the syllabus flows topic-by-topic.</a:t>
             </a:r>
             <a:endParaRPr lang="en-US" sz="1150" dirty="0"/>
           </a:p>
@@ -2043,7 +2043,7 @@
                 <a:ea typeface="Calibri" pitchFamily="34" charset="-122"/>
                 <a:cs typeface="Calibri" pitchFamily="34" charset="-120"/>
               </a:rPr>
-              <a:t>End-to-end mentorship</a:t>
+              <a:t>Materials &amp; resources</a:t>
             </a:r>
             <a:endParaRPr lang="en-US" sz="1500" dirty="0"/>
           </a:p>
@@ -2082,7 +2082,7 @@
                 <a:ea typeface="Calibri" pitchFamily="34" charset="-122"/>
                 <a:cs typeface="Calibri" pitchFamily="34" charset="-120"/>
               </a:rPr>
-              <a:t>USMLE Steps 1 &amp; 2 CK, ECFMG application, CV, personal statement, interviews, and the residency match.</a:t>
+              <a:t>Recommended textbook, Qbank, and curated supplements walked through together.</a:t>
             </a:r>
             <a:endParaRPr lang="en-US" sz="1150" dirty="0"/>
           </a:p>
@@ -2242,7 +2242,7 @@
                 <a:ea typeface="Calibri" pitchFamily="34" charset="-122"/>
                 <a:cs typeface="Calibri" pitchFamily="34" charset="-120"/>
               </a:rPr>
-              <a:t>Cost &amp; enrollment</a:t>
+              <a:t>End-to-end mentorship</a:t>
             </a:r>
             <a:endParaRPr lang="en-US" sz="1500" dirty="0"/>
           </a:p>
@@ -2281,7 +2281,7 @@
                 <a:ea typeface="Calibri" pitchFamily="34" charset="-122"/>
                 <a:cs typeface="Calibri" pitchFamily="34" charset="-120"/>
               </a:rPr>
-              <a:t>Pricing, payment options, the combined Step 1+2 expedited track, and how to join the July–October cohort.</a:t>
+              <a:t>Through ECFMG application, CV, personal statement, interview prep, and the residency match itself.</a:t>
             </a:r>
             <a:endParaRPr lang="en-US" sz="1150" dirty="0"/>
           </a:p>

</xml_diff>

<commit_message>
Info session poster: QR code + restructured cards (process + classes)
- Added scannable QR code to the right of the Zoom callout,
  encoding https://duke.zoom.us/j/96991939005 (M-level error
  correction, ~1.3in printed). Generated via Python qrcode
  library; tracked at outputs/flyers/zoom_qr.png.
- Card 1: 'The residency journey' (process: ECFMG, timeline, match)
- Card 2: 'How the classes work' (daily, 4-month, materials)
- Card 3: 'Step 1 prep' (foundational sciences, organ systems)
- Card 4: 'Step 2 CK prep' (clinical reasoning, specialties)
- Reflowed Zoom-callout text on the left to leave room for QR
</commit_message>
<xml_diff>
--- a/outputs/flyers/USMLE_InfoSession_Poster.pptx
+++ b/outputs/flyers/USMLE_InfoSession_Poster.pptx
@@ -1645,7 +1645,7 @@
                 <a:ea typeface="Calibri" pitchFamily="34" charset="-122"/>
                 <a:cs typeface="Calibri" pitchFamily="34" charset="-120"/>
               </a:rPr>
-              <a:t>The USMLE &amp; residency path</a:t>
+              <a:t>The residency journey</a:t>
             </a:r>
             <a:endParaRPr lang="en-US" sz="1500" dirty="0"/>
           </a:p>
@@ -1684,7 +1684,7 @@
                 <a:ea typeface="Calibri" pitchFamily="34" charset="-122"/>
                 <a:cs typeface="Calibri" pitchFamily="34" charset="-120"/>
               </a:rPr>
-              <a:t>What Step 1 &amp; Step 2 CK actually test, eligibility for IMGs, and the prep + match timeline overview.</a:t>
+              <a:t>From MD to US residency: ECFMG eligibility, the exam timeline, and how the match cycle works.</a:t>
             </a:r>
             <a:endParaRPr lang="en-US" sz="1150" dirty="0"/>
           </a:p>
@@ -1844,7 +1844,7 @@
                 <a:ea typeface="Calibri" pitchFamily="34" charset="-122"/>
                 <a:cs typeface="Calibri" pitchFamily="34" charset="-120"/>
               </a:rPr>
-              <a:t>Course structure</a:t>
+              <a:t>How the classes work</a:t>
             </a:r>
             <a:endParaRPr lang="en-US" sz="1500" dirty="0"/>
           </a:p>
@@ -1883,7 +1883,7 @@
                 <a:ea typeface="Calibri" pitchFamily="34" charset="-122"/>
                 <a:cs typeface="Calibri" pitchFamily="34" charset="-120"/>
               </a:rPr>
-              <a:t>Daily Mon–Sun classes, 4-month roadmap, how the syllabus flows topic-by-topic.</a:t>
+              <a:t>Daily Mon–Sun sessions, 4-month roadmap, full textbook + Qbank walkthrough, office hours outside class.</a:t>
             </a:r>
             <a:endParaRPr lang="en-US" sz="1150" dirty="0"/>
           </a:p>
@@ -2043,7 +2043,7 @@
                 <a:ea typeface="Calibri" pitchFamily="34" charset="-122"/>
                 <a:cs typeface="Calibri" pitchFamily="34" charset="-120"/>
               </a:rPr>
-              <a:t>Materials &amp; resources</a:t>
+              <a:t>Step 1 prep</a:t>
             </a:r>
             <a:endParaRPr lang="en-US" sz="1500" dirty="0"/>
           </a:p>
@@ -2082,7 +2082,7 @@
                 <a:ea typeface="Calibri" pitchFamily="34" charset="-122"/>
                 <a:cs typeface="Calibri" pitchFamily="34" charset="-120"/>
               </a:rPr>
-              <a:t>Recommended textbook, Qbank, and curated supplements walked through together.</a:t>
+              <a:t>Foundational sciences (Pathology, Physiology, Pharm, and the rest) across all the high-yield organ systems.</a:t>
             </a:r>
             <a:endParaRPr lang="en-US" sz="1150" dirty="0"/>
           </a:p>
@@ -2242,7 +2242,7 @@
                 <a:ea typeface="Calibri" pitchFamily="34" charset="-122"/>
                 <a:cs typeface="Calibri" pitchFamily="34" charset="-120"/>
               </a:rPr>
-              <a:t>End-to-end mentorship</a:t>
+              <a:t>Step 2 CK prep</a:t>
             </a:r>
             <a:endParaRPr lang="en-US" sz="1500" dirty="0"/>
           </a:p>
@@ -2281,7 +2281,7 @@
                 <a:ea typeface="Calibri" pitchFamily="34" charset="-122"/>
                 <a:cs typeface="Calibri" pitchFamily="34" charset="-120"/>
               </a:rPr>
-              <a:t>Through ECFMG application, CV, personal statement, interview prep, and the residency match itself.</a:t>
+              <a:t>Clinical reasoning across Medicine, Surgery, Pediatrics, OB/GYN, Psychiatry, and Family Medicine — case-based.</a:t>
             </a:r>
             <a:endParaRPr lang="en-US" sz="1150" dirty="0"/>
           </a:p>
@@ -2371,7 +2371,7 @@
         <p:spPr>
           <a:xfrm>
             <a:off x="731520" y="6281928"/>
-            <a:ext cx="6492240" cy="237744"/>
+            <a:ext cx="5102352" cy="237744"/>
           </a:xfrm>
           <a:prstGeom prst="rect">
             <a:avLst/>
@@ -2410,7 +2410,7 @@
         <p:spPr>
           <a:xfrm>
             <a:off x="731520" y="6501384"/>
-            <a:ext cx="6492240" cy="274320"/>
+            <a:ext cx="5102352" cy="256032"/>
           </a:xfrm>
           <a:prstGeom prst="rect">
             <a:avLst/>
@@ -2426,7 +2426,7 @@
               <a:buNone/>
             </a:pPr>
             <a:r>
-              <a:rPr lang="en-US" sz="1400" b="1" dirty="0">
+              <a:rPr lang="en-US" sz="1300" b="1" dirty="0">
                 <a:solidFill>
                   <a:srgbClr val="FFFFFF"/>
                 </a:solidFill>
@@ -2434,9 +2434,9 @@
                 <a:ea typeface="Calibri" pitchFamily="34" charset="-122"/>
                 <a:cs typeface="Calibri" pitchFamily="34" charset="-120"/>
               </a:rPr>
-              <a:t>Saturday, May 9, 2026  ·  11:00 AM EDT  ·  6:00 PM EAT</a:t>
-            </a:r>
-            <a:endParaRPr lang="en-US" sz="1400" dirty="0"/>
+              <a:t>Saturday, May 9, 2026</a:t>
+            </a:r>
+            <a:endParaRPr lang="en-US" sz="1300" dirty="0"/>
           </a:p>
         </p:txBody>
       </p:sp>
@@ -2448,8 +2448,8 @@
         </p:nvSpPr>
         <p:spPr>
           <a:xfrm>
-            <a:off x="731520" y="6793992"/>
-            <a:ext cx="6492240" cy="384048"/>
+            <a:off x="731520" y="6739128"/>
+            <a:ext cx="5102352" cy="237744"/>
           </a:xfrm>
           <a:prstGeom prst="rect">
             <a:avLst/>
@@ -2465,7 +2465,46 @@
               <a:buNone/>
             </a:pPr>
             <a:r>
-              <a:rPr lang="en-US" sz="2200" b="1" dirty="0">
+              <a:rPr lang="en-US" sz="1200" dirty="0">
+                <a:solidFill>
+                  <a:srgbClr val="FFFFFF"/>
+                </a:solidFill>
+                <a:latin typeface="Calibri" pitchFamily="34" charset="0"/>
+                <a:ea typeface="Calibri" pitchFamily="34" charset="-122"/>
+                <a:cs typeface="Calibri" pitchFamily="34" charset="-120"/>
+              </a:rPr>
+              <a:t>11:00 AM EDT  ·  6:00 PM EAT</a:t>
+            </a:r>
+            <a:endParaRPr lang="en-US" sz="1200" dirty="0"/>
+          </a:p>
+        </p:txBody>
+      </p:sp>
+      <p:sp>
+        <p:nvSpPr>
+          <p:cNvPr id="50" name="Text 47"/>
+          <p:cNvSpPr/>
+          <p:nvPr/>
+        </p:nvSpPr>
+        <p:spPr>
+          <a:xfrm>
+            <a:off x="731520" y="6995160"/>
+            <a:ext cx="5102352" cy="329184"/>
+          </a:xfrm>
+          <a:prstGeom prst="rect">
+            <a:avLst/>
+          </a:prstGeom>
+          <a:noFill/>
+          <a:ln/>
+        </p:spPr>
+        <p:txBody>
+          <a:bodyPr wrap="square" lIns="0" tIns="0" rIns="0" bIns="0" rtlCol="0" anchor="ctr"/>
+          <a:lstStyle/>
+          <a:p>
+            <a:pPr indent="0" marL="0">
+              <a:buNone/>
+            </a:pPr>
+            <a:r>
+              <a:rPr lang="en-US" sz="1800" b="1" dirty="0">
                 <a:solidFill>
                   <a:srgbClr val="FFFFFF"/>
                 </a:solidFill>
@@ -2475,20 +2514,20 @@
               </a:rPr>
               <a:t>duke.zoom.us/j/96991939005</a:t>
             </a:r>
-            <a:endParaRPr lang="en-US" sz="2200" dirty="0"/>
-          </a:p>
-        </p:txBody>
-      </p:sp>
-      <p:sp>
-        <p:nvSpPr>
-          <p:cNvPr id="50" name="Text 47"/>
-          <p:cNvSpPr/>
-          <p:nvPr/>
-        </p:nvSpPr>
-        <p:spPr>
-          <a:xfrm>
-            <a:off x="731520" y="7196328"/>
-            <a:ext cx="6492240" cy="274320"/>
+            <a:endParaRPr lang="en-US" sz="1800" dirty="0"/>
+          </a:p>
+        </p:txBody>
+      </p:sp>
+      <p:sp>
+        <p:nvSpPr>
+          <p:cNvPr id="51" name="Text 48"/>
+          <p:cNvSpPr/>
+          <p:nvPr/>
+        </p:nvSpPr>
+        <p:spPr>
+          <a:xfrm>
+            <a:off x="731520" y="7306056"/>
+            <a:ext cx="5102352" cy="219456"/>
           </a:xfrm>
           <a:prstGeom prst="rect">
             <a:avLst/>
@@ -2504,7 +2543,7 @@
               <a:buNone/>
             </a:pPr>
             <a:r>
-              <a:rPr lang="en-US" sz="1200" dirty="0">
+              <a:rPr lang="en-US" sz="1050" dirty="0">
                 <a:solidFill>
                   <a:srgbClr val="FFFFFF"/>
                 </a:solidFill>
@@ -2514,52 +2553,13 @@
               </a:rPr>
               <a:t>Meeting ID: 969 9193 9005</a:t>
             </a:r>
-            <a:endParaRPr lang="en-US" sz="1200" dirty="0"/>
-          </a:p>
-        </p:txBody>
-      </p:sp>
-      <p:sp>
-        <p:nvSpPr>
-          <p:cNvPr id="51" name="Text 48"/>
-          <p:cNvSpPr/>
-          <p:nvPr/>
-        </p:nvSpPr>
-        <p:spPr>
-          <a:xfrm>
-            <a:off x="457200" y="7818120"/>
-            <a:ext cx="6858000" cy="219456"/>
-          </a:xfrm>
-          <a:prstGeom prst="rect">
-            <a:avLst/>
-          </a:prstGeom>
-          <a:noFill/>
-          <a:ln/>
-        </p:spPr>
-        <p:txBody>
-          <a:bodyPr wrap="square" lIns="0" tIns="0" rIns="0" bIns="0" rtlCol="0" anchor="ctr"/>
-          <a:lstStyle/>
-          <a:p>
-            <a:pPr indent="0" marL="0">
-              <a:buNone/>
-            </a:pPr>
-            <a:r>
-              <a:rPr lang="en-US" sz="1100" b="1" spc="400" kern="0" dirty="0">
-                <a:solidFill>
-                  <a:srgbClr val="075985"/>
-                </a:solidFill>
-                <a:latin typeface="Calibri" pitchFamily="34" charset="0"/>
-                <a:ea typeface="Calibri" pitchFamily="34" charset="-122"/>
-                <a:cs typeface="Calibri" pitchFamily="34" charset="-120"/>
-              </a:rPr>
-              <a:t>CAN'T MAKE IT? CONTACT ALLAN ANY TIME ON:</a:t>
-            </a:r>
-            <a:endParaRPr lang="en-US" sz="1100" dirty="0"/>
+            <a:endParaRPr lang="en-US" sz="1050" dirty="0"/>
           </a:p>
         </p:txBody>
       </p:sp>
       <p:pic>
         <p:nvPicPr>
-          <p:cNvPr id="52" name="Image 1" descr="email-blue.png">    </p:cNvPr>
+          <p:cNvPr id="52" name="Image 1" descr="zoom_qr.png">    </p:cNvPr>
           <p:cNvPicPr>
             <a:picLocks noChangeAspect="1"/>
           </p:cNvPicPr>
@@ -2573,8 +2573,8 @@
         </p:blipFill>
         <p:spPr>
           <a:xfrm>
-            <a:off x="457200" y="8101584"/>
-            <a:ext cx="237744" cy="237744"/>
+            <a:off x="6016752" y="6286500"/>
+            <a:ext cx="1188720" cy="1188720"/>
           </a:xfrm>
           <a:prstGeom prst="rect">
             <a:avLst/>
@@ -2589,40 +2589,79 @@
         </p:nvSpPr>
         <p:spPr>
           <a:xfrm>
-            <a:off x="768096" y="8074152"/>
-            <a:ext cx="2026310" cy="292608"/>
-          </a:xfrm>
-          <a:prstGeom prst="rect">
-            <a:avLst/>
-          </a:prstGeom>
-          <a:noFill/>
-          <a:ln/>
-        </p:spPr>
-        <p:txBody>
-          <a:bodyPr wrap="square" lIns="0" tIns="0" rIns="0" bIns="0" rtlCol="0" anchor="ctr"/>
-          <a:lstStyle/>
-          <a:p>
-            <a:pPr algn="l" indent="0" marL="0">
-              <a:buNone/>
-            </a:pPr>
-            <a:r>
-              <a:rPr lang="en-US" sz="1200" b="1" dirty="0">
-                <a:solidFill>
-                  <a:srgbClr val="0C2A3D"/>
+            <a:off x="6016752" y="7429500"/>
+            <a:ext cx="1188720" cy="164592"/>
+          </a:xfrm>
+          <a:prstGeom prst="rect">
+            <a:avLst/>
+          </a:prstGeom>
+          <a:noFill/>
+          <a:ln/>
+        </p:spPr>
+        <p:txBody>
+          <a:bodyPr wrap="square" lIns="0" tIns="0" rIns="0" bIns="0" rtlCol="0" anchor="ctr"/>
+          <a:lstStyle/>
+          <a:p>
+            <a:pPr algn="ctr" indent="0" marL="0">
+              <a:buNone/>
+            </a:pPr>
+            <a:r>
+              <a:rPr lang="en-US" sz="800" i="1" dirty="0">
+                <a:solidFill>
+                  <a:srgbClr val="075985"/>
                 </a:solidFill>
                 <a:latin typeface="Calibri" pitchFamily="34" charset="0"/>
                 <a:ea typeface="Calibri" pitchFamily="34" charset="-122"/>
                 <a:cs typeface="Calibri" pitchFamily="34" charset="-120"/>
               </a:rPr>
-              <a:t>allanbakesiga@gmail.com</a:t>
-            </a:r>
-            <a:endParaRPr lang="en-US" sz="1200" dirty="0"/>
+              <a:t>scan to join</a:t>
+            </a:r>
+            <a:endParaRPr lang="en-US" sz="800" dirty="0"/>
+          </a:p>
+        </p:txBody>
+      </p:sp>
+      <p:sp>
+        <p:nvSpPr>
+          <p:cNvPr id="54" name="Text 50"/>
+          <p:cNvSpPr/>
+          <p:nvPr/>
+        </p:nvSpPr>
+        <p:spPr>
+          <a:xfrm>
+            <a:off x="457200" y="7818120"/>
+            <a:ext cx="6858000" cy="219456"/>
+          </a:xfrm>
+          <a:prstGeom prst="rect">
+            <a:avLst/>
+          </a:prstGeom>
+          <a:noFill/>
+          <a:ln/>
+        </p:spPr>
+        <p:txBody>
+          <a:bodyPr wrap="square" lIns="0" tIns="0" rIns="0" bIns="0" rtlCol="0" anchor="ctr"/>
+          <a:lstStyle/>
+          <a:p>
+            <a:pPr indent="0" marL="0">
+              <a:buNone/>
+            </a:pPr>
+            <a:r>
+              <a:rPr lang="en-US" sz="1100" b="1" spc="400" kern="0" dirty="0">
+                <a:solidFill>
+                  <a:srgbClr val="075985"/>
+                </a:solidFill>
+                <a:latin typeface="Calibri" pitchFamily="34" charset="0"/>
+                <a:ea typeface="Calibri" pitchFamily="34" charset="-122"/>
+                <a:cs typeface="Calibri" pitchFamily="34" charset="-120"/>
+              </a:rPr>
+              <a:t>CAN'T MAKE IT? CONTACT ALLAN ANY TIME ON:</a:t>
+            </a:r>
+            <a:endParaRPr lang="en-US" sz="1100" dirty="0"/>
           </a:p>
         </p:txBody>
       </p:sp>
       <p:pic>
         <p:nvPicPr>
-          <p:cNvPr id="54" name="Image 2" descr="whatsapp.png">    </p:cNvPr>
+          <p:cNvPr id="55" name="Image 2" descr="email-blue.png">    </p:cNvPr>
           <p:cNvPicPr>
             <a:picLocks noChangeAspect="1"/>
           </p:cNvPicPr>
@@ -2636,8 +2675,8 @@
         </p:blipFill>
         <p:spPr>
           <a:xfrm>
-            <a:off x="3048610" y="8092440"/>
-            <a:ext cx="256032" cy="256032"/>
+            <a:off x="457200" y="8101584"/>
+            <a:ext cx="237744" cy="237744"/>
           </a:xfrm>
           <a:prstGeom prst="rect">
             <a:avLst/>
@@ -2646,14 +2685,14 @@
       </p:pic>
       <p:sp>
         <p:nvSpPr>
-          <p:cNvPr id="55" name="Text 50"/>
-          <p:cNvSpPr/>
-          <p:nvPr/>
-        </p:nvSpPr>
-        <p:spPr>
-          <a:xfrm>
-            <a:off x="3377794" y="8074152"/>
-            <a:ext cx="1437437" cy="292608"/>
+          <p:cNvPr id="56" name="Text 51"/>
+          <p:cNvSpPr/>
+          <p:nvPr/>
+        </p:nvSpPr>
+        <p:spPr>
+          <a:xfrm>
+            <a:off x="768096" y="8074152"/>
+            <a:ext cx="2026310" cy="292608"/>
           </a:xfrm>
           <a:prstGeom prst="rect">
             <a:avLst/>
@@ -2677,7 +2716,7 @@
                 <a:ea typeface="Calibri" pitchFamily="34" charset="-122"/>
                 <a:cs typeface="Calibri" pitchFamily="34" charset="-120"/>
               </a:rPr>
-              <a:t>+256 705 571 443</a:t>
+              <a:t>allanbakesiga@gmail.com</a:t>
             </a:r>
             <a:endParaRPr lang="en-US" sz="1200" dirty="0"/>
           </a:p>
@@ -2685,7 +2724,7 @@
       </p:sp>
       <p:pic>
         <p:nvPicPr>
-          <p:cNvPr id="56" name="Image 3" descr="phone-blue.png">    </p:cNvPr>
+          <p:cNvPr id="57" name="Image 3" descr="whatsapp.png">    </p:cNvPr>
           <p:cNvPicPr>
             <a:picLocks noChangeAspect="1"/>
           </p:cNvPicPr>
@@ -2699,8 +2738,8 @@
         </p:blipFill>
         <p:spPr>
           <a:xfrm>
-            <a:off x="5440680" y="8101584"/>
-            <a:ext cx="237744" cy="237744"/>
+            <a:off x="3048610" y="8092440"/>
+            <a:ext cx="256032" cy="256032"/>
           </a:xfrm>
           <a:prstGeom prst="rect">
             <a:avLst/>
@@ -2709,14 +2748,14 @@
       </p:pic>
       <p:sp>
         <p:nvSpPr>
-          <p:cNvPr id="57" name="Text 51"/>
-          <p:cNvSpPr/>
-          <p:nvPr/>
-        </p:nvSpPr>
-        <p:spPr>
-          <a:xfrm>
-            <a:off x="5751576" y="8074152"/>
-            <a:ext cx="1353312" cy="292608"/>
+          <p:cNvPr id="58" name="Text 52"/>
+          <p:cNvSpPr/>
+          <p:nvPr/>
+        </p:nvSpPr>
+        <p:spPr>
+          <a:xfrm>
+            <a:off x="3377794" y="8074152"/>
+            <a:ext cx="1437437" cy="292608"/>
           </a:xfrm>
           <a:prstGeom prst="rect">
             <a:avLst/>
@@ -2740,45 +2779,108 @@
                 <a:ea typeface="Calibri" pitchFamily="34" charset="-122"/>
                 <a:cs typeface="Calibri" pitchFamily="34" charset="-120"/>
               </a:rPr>
-              <a:t>+1 984 710 2902</a:t>
+              <a:t>+256 705 571 443</a:t>
             </a:r>
             <a:endParaRPr lang="en-US" sz="1200" dirty="0"/>
           </a:p>
         </p:txBody>
       </p:sp>
-      <p:sp>
-        <p:nvSpPr>
-          <p:cNvPr id="58" name="Text 52"/>
-          <p:cNvSpPr/>
-          <p:nvPr/>
-        </p:nvSpPr>
-        <p:spPr>
-          <a:xfrm>
-            <a:off x="457200" y="8604504"/>
-            <a:ext cx="6858000" cy="201168"/>
-          </a:xfrm>
-          <a:prstGeom prst="rect">
-            <a:avLst/>
-          </a:prstGeom>
-          <a:noFill/>
-          <a:ln/>
-        </p:spPr>
-        <p:txBody>
-          <a:bodyPr wrap="square" lIns="0" tIns="0" rIns="0" bIns="0" rtlCol="0" anchor="ctr"/>
-          <a:lstStyle/>
-          <a:p>
-            <a:pPr indent="0" marL="0">
-              <a:buNone/>
-            </a:pPr>
-            <a:r>
-              <a:rPr lang="en-US" sz="1050" i="1" dirty="0">
-                <a:solidFill>
-                  <a:srgbClr val="345671"/>
+      <p:pic>
+        <p:nvPicPr>
+          <p:cNvPr id="59" name="Image 4" descr="phone-blue.png">    </p:cNvPr>
+          <p:cNvPicPr>
+            <a:picLocks noChangeAspect="1"/>
+          </p:cNvPicPr>
+          <p:nvPr/>
+        </p:nvPicPr>
+        <p:blipFill>
+          <a:blip r:embed="rId5"/>
+          <a:stretch>
+            <a:fillRect/>
+          </a:stretch>
+        </p:blipFill>
+        <p:spPr>
+          <a:xfrm>
+            <a:off x="5440680" y="8101584"/>
+            <a:ext cx="237744" cy="237744"/>
+          </a:xfrm>
+          <a:prstGeom prst="rect">
+            <a:avLst/>
+          </a:prstGeom>
+        </p:spPr>
+      </p:pic>
+      <p:sp>
+        <p:nvSpPr>
+          <p:cNvPr id="60" name="Text 53"/>
+          <p:cNvSpPr/>
+          <p:nvPr/>
+        </p:nvSpPr>
+        <p:spPr>
+          <a:xfrm>
+            <a:off x="5751576" y="8074152"/>
+            <a:ext cx="1353312" cy="292608"/>
+          </a:xfrm>
+          <a:prstGeom prst="rect">
+            <a:avLst/>
+          </a:prstGeom>
+          <a:noFill/>
+          <a:ln/>
+        </p:spPr>
+        <p:txBody>
+          <a:bodyPr wrap="square" lIns="0" tIns="0" rIns="0" bIns="0" rtlCol="0" anchor="ctr"/>
+          <a:lstStyle/>
+          <a:p>
+            <a:pPr algn="l" indent="0" marL="0">
+              <a:buNone/>
+            </a:pPr>
+            <a:r>
+              <a:rPr lang="en-US" sz="1200" b="1" dirty="0">
+                <a:solidFill>
+                  <a:srgbClr val="0C2A3D"/>
                 </a:solidFill>
                 <a:latin typeface="Calibri" pitchFamily="34" charset="0"/>
                 <a:ea typeface="Calibri" pitchFamily="34" charset="-122"/>
                 <a:cs typeface="Calibri" pitchFamily="34" charset="-120"/>
               </a:rPr>
+              <a:t>+1 984 710 2902</a:t>
+            </a:r>
+            <a:endParaRPr lang="en-US" sz="1200" dirty="0"/>
+          </a:p>
+        </p:txBody>
+      </p:sp>
+      <p:sp>
+        <p:nvSpPr>
+          <p:cNvPr id="61" name="Text 54"/>
+          <p:cNvSpPr/>
+          <p:nvPr/>
+        </p:nvSpPr>
+        <p:spPr>
+          <a:xfrm>
+            <a:off x="457200" y="8604504"/>
+            <a:ext cx="6858000" cy="201168"/>
+          </a:xfrm>
+          <a:prstGeom prst="rect">
+            <a:avLst/>
+          </a:prstGeom>
+          <a:noFill/>
+          <a:ln/>
+        </p:spPr>
+        <p:txBody>
+          <a:bodyPr wrap="square" lIns="0" tIns="0" rIns="0" bIns="0" rtlCol="0" anchor="ctr"/>
+          <a:lstStyle/>
+          <a:p>
+            <a:pPr indent="0" marL="0">
+              <a:buNone/>
+            </a:pPr>
+            <a:r>
+              <a:rPr lang="en-US" sz="1050" i="1" dirty="0">
+                <a:solidFill>
+                  <a:srgbClr val="345671"/>
+                </a:solidFill>
+                <a:latin typeface="Calibri" pitchFamily="34" charset="0"/>
+                <a:ea typeface="Calibri" pitchFamily="34" charset="-122"/>
+                <a:cs typeface="Calibri" pitchFamily="34" charset="-120"/>
+              </a:rPr>
               <a:t>Course materials and class recordings live at:</a:t>
             </a:r>
             <a:endParaRPr lang="en-US" sz="1050" dirty="0"/>
@@ -2787,7 +2889,7 @@
       </p:sp>
       <p:sp>
         <p:nvSpPr>
-          <p:cNvPr id="59" name="Text 53"/>
+          <p:cNvPr id="62" name="Text 55"/>
           <p:cNvSpPr/>
           <p:nvPr/>
         </p:nvSpPr>
@@ -2826,7 +2928,7 @@
       </p:sp>
       <p:sp>
         <p:nvSpPr>
-          <p:cNvPr id="60" name="Shape 54"/>
+          <p:cNvPr id="63" name="Shape 56"/>
           <p:cNvSpPr/>
           <p:nvPr/>
         </p:nvSpPr>
@@ -2851,7 +2953,7 @@
       </p:sp>
       <p:sp>
         <p:nvSpPr>
-          <p:cNvPr id="61" name="Shape 55"/>
+          <p:cNvPr id="64" name="Shape 57"/>
           <p:cNvSpPr/>
           <p:nvPr/>
         </p:nvSpPr>
@@ -2876,7 +2978,7 @@
       </p:sp>
       <p:sp>
         <p:nvSpPr>
-          <p:cNvPr id="62" name="Shape 56"/>
+          <p:cNvPr id="65" name="Shape 58"/>
           <p:cNvSpPr/>
           <p:nvPr/>
         </p:nvSpPr>
@@ -2901,7 +3003,7 @@
       </p:sp>
       <p:sp>
         <p:nvSpPr>
-          <p:cNvPr id="63" name="Shape 57"/>
+          <p:cNvPr id="66" name="Shape 59"/>
           <p:cNvSpPr/>
           <p:nvPr/>
         </p:nvSpPr>

</xml_diff>

<commit_message>
Info session poster: replace dashboard URL with form sign-up
After the info session, attendees who want to enrol go through
the same Google Form (forms.gle/Pj4tB985kpZGBKN59) as everyone
else. Bottom of poster updated accordingly. Zoom callout + QR
remain primary for joining the session itself.
</commit_message>
<xml_diff>
--- a/outputs/flyers/USMLE_InfoSession_Poster.pptx
+++ b/outputs/flyers/USMLE_InfoSession_Poster.pptx
@@ -2881,7 +2881,7 @@
                 <a:ea typeface="Calibri" pitchFamily="34" charset="-122"/>
                 <a:cs typeface="Calibri" pitchFamily="34" charset="-120"/>
               </a:rPr>
-              <a:t>Course materials and class recordings live at:</a:t>
+              <a:t>Ready to enrol? Drop your details here and Allan will follow up:</a:t>
             </a:r>
             <a:endParaRPr lang="en-US" sz="1050" dirty="0"/>
           </a:p>
@@ -2920,7 +2920,7 @@
                 <a:ea typeface="Arial Black" pitchFamily="34" charset="-122"/>
                 <a:cs typeface="Arial Black" pitchFamily="34" charset="-120"/>
               </a:rPr>
-              <a:t>bakesiga.github.io/usmle-dashboard</a:t>
+              <a:t>forms.gle/Pj4tB985kpZGBKN59</a:t>
             </a:r>
             <a:endParaRPr lang="en-US" sz="2200" dirty="0"/>
           </a:p>

</xml_diff>

<commit_message>
Info session poster: point bottom CTA to public website
Now that the site is a public marketing page (with the
sign-up form embedded), the info session poster's closing
URL is more useful as bakesiga.github.io/usmle-dashboard
than the bare forms.gle link. Visitors land on the website,
see the curriculum and Allan's bio, and can sign up there.
</commit_message>
<xml_diff>
--- a/outputs/flyers/USMLE_InfoSession_Poster.pptx
+++ b/outputs/flyers/USMLE_InfoSession_Poster.pptx
@@ -2881,7 +2881,7 @@
                 <a:ea typeface="Calibri" pitchFamily="34" charset="-122"/>
                 <a:cs typeface="Calibri" pitchFamily="34" charset="-120"/>
               </a:rPr>
-              <a:t>Ready to enrol? Drop your details here and Allan will follow up:</a:t>
+              <a:t>Learn more about the cohort or sign up here:</a:t>
             </a:r>
             <a:endParaRPr lang="en-US" sz="1050" dirty="0"/>
           </a:p>
@@ -2920,7 +2920,7 @@
                 <a:ea typeface="Arial Black" pitchFamily="34" charset="-122"/>
                 <a:cs typeface="Arial Black" pitchFamily="34" charset="-120"/>
               </a:rPr>
-              <a:t>forms.gle/Pj4tB985kpZGBKN59</a:t>
+              <a:t>bakesiga.github.io/usmle-dashboard</a:t>
             </a:r>
             <a:endParaRPr lang="en-US" sz="2200" dirty="0"/>
           </a:p>

</xml_diff>